<commit_message>
Document flexible primary/aux model selection and improve web dev workflow.
Treat RF/CatBoost as evaluation snapshots, not fixed roles; add RestartWeb, launcher, and Cursor hooks for faster restarts.

Co-authored-by: Cursor <cursoragent@cursor.com>
</commit_message>
<xml_diff>
--- a/docs/project_introduction.pptx
+++ b/docs/project_introduction.pptx
@@ -7418,7 +7418,7 @@
                           </a:solidFill>
                           <a:latin typeface="맑은 고딕"/>
                         </a:rPr>
-                        <a:t>RF+CatBoost만</a:t>
+                        <a:t>주·보 2종만</a:t>
                       </a:r>
                     </a:p>
                   </a:txBody>
@@ -10639,7 +10639,7 @@
                 </a:solidFill>
                 <a:latin typeface="맑은 고딕"/>
               </a:rPr>
-              <a:t>추론 RF+CatBoost</a:t>
+              <a:t>추론(주·보)</a:t>
             </a:r>
           </a:p>
         </p:txBody>
@@ -11519,7 +11519,7 @@
                 </a:solidFill>
                 <a:latin typeface="맑은 고딕"/>
               </a:rPr>
-              <a:t>RF+CatBoost만 선택</a:t>
+              <a:t>주·보 2종만 선택</a:t>
             </a:r>
           </a:p>
         </p:txBody>
@@ -11713,7 +11713,7 @@
                 </a:solidFill>
                 <a:latin typeface="맑은 고딕"/>
               </a:rPr>
-              <a:t>운영 기본 충분</a:t>
+              <a:t>4×4에 충분</a:t>
             </a:r>
           </a:p>
         </p:txBody>
@@ -13997,11 +13997,11 @@
                 </a:solidFill>
                 <a:latin typeface="맑은 고딕"/>
               </a:rPr>
-              <a:t>★ 주 운영: RandomForest</a:t>
+              <a:t>★ 주 모델 (primary)</a:t>
             </a:r>
             <a:br/>
             <a:r>
-              <a:t>점수·점검 우선순위의 기본</a:t>
+              <a:t>평가·순위로 선정 · 4×4 1차 기준</a:t>
             </a:r>
           </a:p>
         </p:txBody>
@@ -14055,11 +14055,11 @@
                 </a:solidFill>
                 <a:latin typeface="맑은 고딕"/>
               </a:rPr>
-              <a:t>★ 보조: CatBoost</a:t>
+              <a:t>★ 보조 모델 (aux)</a:t>
             </a:r>
             <a:br/>
             <a:r>
-              <a:t>교차 확인·미탐 보완</a:t>
+              <a:t>교차 확인 · 동등급 정렬</a:t>
             </a:r>
           </a:p>
         </p:txBody>
@@ -15202,7 +15202,7 @@
                 </a:solidFill>
                 <a:latin typeface="맑은 고딕"/>
               </a:rPr>
-              <a:t>RF+CatBoost만 권장</a:t>
+              <a:t>주·보 2종만 권장</a:t>
             </a:r>
           </a:p>
         </p:txBody>

</xml_diff>